<commit_message>
Simplify presentation wording and remove em dashes
Co-Authored-By: Claude Opus 4.8 <noreply@anthropic.com>
</commit_message>
<xml_diff>
--- a/deliverables/Nitish_Kumar_Presentation.pptx
+++ b/deliverables/Nitish_Kumar_Presentation.pptx
@@ -3904,7 +3904,7 @@
                 </a:solidFill>
                 <a:latin typeface="Calibri"/>
               </a:rPr>
-              <a:t>Clinical value—diagnoses, procedures, and the evidence behind every claim—lives in free-text notes, scanned faxes, and medical images that cannot be directly queried, coded, or audited.</a:t>
+              <a:t>The details that matter (diagnoses, procedures, and the proof behind every claim) sit in free-text notes, scanned faxes, and images. Computers cannot search, code, or audit them directly.</a:t>
             </a:r>
           </a:p>
         </p:txBody>
@@ -4049,7 +4049,7 @@
                 </a:solidFill>
                 <a:latin typeface="Calibri"/>
               </a:rPr>
-              <a:t>Physician notes, discharge summaries, pathology narratives</a:t>
+              <a:t>Physician notes, discharge summaries, pathology reports</a:t>
             </a:r>
           </a:p>
         </p:txBody>
@@ -4194,7 +4194,7 @@
                 </a:solidFill>
                 <a:latin typeface="Calibri"/>
               </a:rPr>
-              <a:t>Faxed orders &amp; referrals digitized via OCR</a:t>
+              <a:t>Faxed orders and referrals digitized with OCR</a:t>
             </a:r>
           </a:p>
         </p:txBody>
@@ -4339,7 +4339,7 @@
                 </a:solidFill>
                 <a:latin typeface="Calibri"/>
               </a:rPr>
-              <a:t>X-ray, CT &amp; MRI read by computer vision</a:t>
+              <a:t>X-ray, CT and MRI read by computer vision</a:t>
             </a:r>
           </a:p>
         </p:txBody>
@@ -4484,7 +4484,7 @@
                 </a:solidFill>
                 <a:latin typeface="Calibri"/>
               </a:rPr>
-              <a:t>The structured ICD / CPT output payment integrity needs</a:t>
+              <a:t>The clean ICD / CPT codes payment integrity needs</a:t>
             </a:r>
           </a:p>
         </p:txBody>
@@ -4523,7 +4523,7 @@
                 </a:solidFill>
                 <a:latin typeface="Calibri"/>
               </a:rPr>
-              <a:t>Clinical NLP technology turns all four into machine-actionable data—the foundation of coding accuracy, payment integrity, and quality measurement.</a:t>
+              <a:t>Clinical NLP turns all four into structured data. That is the foundation for accurate coding, payment integrity, and quality measurement.</a:t>
             </a:r>
           </a:p>
         </p:txBody>
@@ -4845,7 +4845,7 @@
                 </a:solidFill>
                 <a:latin typeface="Calibri"/>
               </a:rPr>
-              <a:t>PAST   2000–2017</a:t>
+              <a:t>PAST   2000-2017</a:t>
             </a:r>
           </a:p>
           <a:p>
@@ -4861,7 +4861,7 @@
                 </a:solidFill>
                 <a:latin typeface="Calibri"/>
               </a:rPr>
-              <a:t>Rule-Based &amp; Dictionary</a:t>
+              <a:t>Rules and Word Lists</a:t>
             </a:r>
           </a:p>
         </p:txBody>
@@ -5022,7 +5022,7 @@
                 </a:solidFill>
                 <a:latin typeface="Calibri"/>
               </a:rPr>
-              <a:t>Hand-crafted patterns &amp; ontologies</a:t>
+              <a:t>Hand-written rules and medical word lists</a:t>
             </a:r>
           </a:p>
           <a:p>
@@ -5038,7 +5038,7 @@
                 </a:solidFill>
                 <a:latin typeface="Calibri"/>
               </a:rPr>
-              <a:t>Accurate but brittle and costly to maintain</a:t>
+              <a:t>Accurate, but fragile and costly to update</a:t>
             </a:r>
           </a:p>
         </p:txBody>
@@ -5121,7 +5121,7 @@
                 </a:solidFill>
                 <a:latin typeface="Calibri"/>
               </a:rPr>
-              <a:t>PRESENT   2018–2023</a:t>
+              <a:t>PRESENT   2018-2023</a:t>
             </a:r>
           </a:p>
           <a:p>
@@ -5137,7 +5137,7 @@
                 </a:solidFill>
                 <a:latin typeface="Calibri"/>
               </a:rPr>
-              <a:t>Transformer Transfer Learning</a:t>
+              <a:t>Learning from Big Data</a:t>
             </a:r>
           </a:p>
         </p:txBody>
@@ -5282,7 +5282,7 @@
                 </a:solidFill>
                 <a:latin typeface="Calibri"/>
               </a:rPr>
-              <a:t>BioBERT, ClinicalBERT, GatorTron encoders</a:t>
+              <a:t>BioBERT, ClinicalBERT, GatorTron models</a:t>
             </a:r>
           </a:p>
           <a:p>
@@ -5298,7 +5298,7 @@
                 </a:solidFill>
                 <a:latin typeface="Calibri"/>
               </a:rPr>
-              <a:t>Expert-level image models: DenseNet, ViT</a:t>
+              <a:t>Image models near expert level: DenseNet, ViT</a:t>
             </a:r>
           </a:p>
           <a:p>
@@ -5314,7 +5314,7 @@
                 </a:solidFill>
                 <a:latin typeface="Calibri"/>
               </a:rPr>
-              <a:t>Strong NER, de-identification, phenotyping</a:t>
+              <a:t>Good at finding terms and hiding patient IDs</a:t>
             </a:r>
           </a:p>
         </p:txBody>
@@ -5397,7 +5397,7 @@
                 </a:solidFill>
                 <a:latin typeface="Calibri"/>
               </a:rPr>
-              <a:t>FUTURE   2024 →</a:t>
+              <a:t>FUTURE   2024 on</a:t>
             </a:r>
           </a:p>
           <a:p>
@@ -5413,7 +5413,7 @@
                 </a:solidFill>
                 <a:latin typeface="Calibri"/>
               </a:rPr>
-              <a:t>Generative &amp; Multimodal</a:t>
+              <a:t>Generative and Multimodal</a:t>
             </a:r>
           </a:p>
         </p:txBody>
@@ -5558,7 +5558,7 @@
                 </a:solidFill>
                 <a:latin typeface="Calibri"/>
               </a:rPr>
-              <a:t>Clinical LLMs (Med-PaLM 2) &amp; LMMs</a:t>
+              <a:t>Clinical LLMs (Med-PaLM 2) and LMMs</a:t>
             </a:r>
           </a:p>
           <a:p>
@@ -5574,7 +5574,7 @@
                 </a:solidFill>
                 <a:latin typeface="Calibri"/>
               </a:rPr>
-              <a:t>One model reads an X-ray, drafts the report</a:t>
+              <a:t>One model reads an X-ray and drafts the report</a:t>
             </a:r>
           </a:p>
           <a:p>
@@ -5590,7 +5590,7 @@
                 </a:solidFill>
                 <a:latin typeface="Calibri"/>
               </a:rPr>
-              <a:t>RAG grounds output &amp; controls hallucination</a:t>
+              <a:t>RAG keeps answers grounded, cuts made-up facts</a:t>
             </a:r>
           </a:p>
         </p:txBody>
@@ -6062,7 +6062,7 @@
                 </a:solidFill>
                 <a:latin typeface="Calibri"/>
               </a:rPr>
-              <a:t>Automated coding &amp; payment integrity — detect miscoding and documentation gaps at scale</a:t>
+              <a:t>Automated coding: find miscoding and missing documentation at scale</a:t>
             </a:r>
           </a:p>
           <a:p>
@@ -6078,7 +6078,7 @@
                 </a:solidFill>
                 <a:latin typeface="Calibri"/>
               </a:rPr>
-              <a:t>Multimodal report generation — faster radiology / pathology turnaround</a:t>
+              <a:t>Report drafting from images: faster radiology and pathology turnaround</a:t>
             </a:r>
           </a:p>
           <a:p>
@@ -6094,7 +6094,7 @@
                 </a:solidFill>
                 <a:latin typeface="Calibri"/>
               </a:rPr>
-              <a:t>Grounded, auditable AI — RAG cites the exact source behind every extraction</a:t>
+              <a:t>Traceable AI: RAG shows the exact source behind every answer</a:t>
             </a:r>
           </a:p>
           <a:p>
@@ -6110,7 +6110,7 @@
                 </a:solidFill>
                 <a:latin typeface="Calibri"/>
               </a:rPr>
-              <a:t>Reviewer productivity — automation triages routine cases to focus experts</a:t>
+              <a:t>More reviewer time: automation handles routine cases so experts focus on the hard ones</a:t>
             </a:r>
           </a:p>
         </p:txBody>
@@ -6239,7 +6239,7 @@
                 </a:solidFill>
                 <a:latin typeface="Calibri"/>
               </a:rPr>
-              <a:t>THREATS &amp; RISKS</a:t>
+              <a:t>THREATS AND RISKS</a:t>
             </a:r>
           </a:p>
           <a:p>
@@ -6255,7 +6255,7 @@
                 </a:solidFill>
                 <a:latin typeface="Calibri"/>
               </a:rPr>
-              <a:t>Hallucination — models can fabricate plausible but false clinical statements</a:t>
+              <a:t>Made-up facts: models can state false things that sound convincing</a:t>
             </a:r>
           </a:p>
           <a:p>
@@ -6271,7 +6271,7 @@
                 </a:solidFill>
                 <a:latin typeface="Calibri"/>
               </a:rPr>
-              <a:t>Privacy &amp; compliance — PHI demands HIPAA-grade de-identification &amp; governance</a:t>
+              <a:t>Privacy: patient data needs HIPAA-grade handling and strict controls</a:t>
             </a:r>
           </a:p>
           <a:p>
@@ -6287,7 +6287,7 @@
                 </a:solidFill>
                 <a:latin typeface="Calibri"/>
               </a:rPr>
-              <a:t>Bias &amp; drift — uneven performance and degradation as coding rules change</a:t>
+              <a:t>Bias and drift: uneven results, and accuracy drops as coding rules change</a:t>
             </a:r>
           </a:p>
           <a:p>
@@ -6303,7 +6303,7 @@
                 </a:solidFill>
                 <a:latin typeface="Calibri"/>
               </a:rPr>
-              <a:t>Regulation — evolving FDA &amp; payer oversight of clinical AI</a:t>
+              <a:t>Regulation: FDA and payer oversight of clinical AI keeps changing</a:t>
             </a:r>
           </a:p>
         </p:txBody>
@@ -6770,7 +6770,7 @@
                 </a:solidFill>
                 <a:latin typeface="Calibri"/>
               </a:rPr>
-              <a:t>Pair domain-pretrained encoders (ClinicalBERT / GatorTron) with a governed RAG store of coding policies &amp; guidelines, so every AI-generated code is traceable to an authoritative source.</a:t>
+              <a:t>Combine medical language models (ClinicalBERT / GatorTron) with a trusted RAG library of coding policies and guidelines, so every AI code links back to an official source.</a:t>
             </a:r>
           </a:p>
         </p:txBody>
@@ -6998,7 +6998,7 @@
                 </a:solidFill>
                 <a:latin typeface="Calibri"/>
               </a:rPr>
-              <a:t>Combine OCR + NLP + computer vision to reconcile imaging and note evidence against submitted claims—closing gaps single-modality review misses.</a:t>
+              <a:t>Use OCR, NLP, and computer vision together to check images and notes against submitted claims, catching gaps that text-only review misses.</a:t>
             </a:r>
           </a:p>
         </p:txBody>
@@ -7210,7 +7210,7 @@
                 </a:solidFill>
                 <a:latin typeface="Calibri"/>
               </a:rPr>
-              <a:t>Human-in-the-Loop MLOps</a:t>
+              <a:t>People in the Loop</a:t>
             </a:r>
           </a:p>
           <a:p>
@@ -7226,7 +7226,7 @@
                 </a:solidFill>
                 <a:latin typeface="Calibri"/>
               </a:rPr>
-              <a:t>Versioning, calibration, drift monitoring, and confidence-gated escalation so automation augments expert reviewers and meets the compliance bar.</a:t>
+              <a:t>Track model versions, watch for drift, and send low-confidence cases to a person, so automation supports expert reviewers and stays compliant.</a:t>
             </a:r>
           </a:p>
         </p:txBody>
@@ -7504,7 +7504,7 @@
                 </a:solidFill>
                 <a:latin typeface="Calibri"/>
               </a:rPr>
-              <a:t>An end-to-end demonstrator: from a raw X-ray to a narrative report and a grounded, auditable clinical Q&amp;A agent.</a:t>
+              <a:t>A full working demo: from a raw X-ray to a written report and a grounded clinical Q&amp;A agent.</a:t>
             </a:r>
           </a:p>
         </p:txBody>
@@ -8128,7 +8128,7 @@
                 </a:solidFill>
                 <a:latin typeface="Calibri"/>
               </a:rPr>
-              <a:t>What It Demonstrates</a:t>
+              <a:t>What It Shows</a:t>
             </a:r>
           </a:p>
           <a:p>
@@ -8144,7 +8144,7 @@
                 </a:solidFill>
                 <a:latin typeface="Calibri"/>
               </a:rPr>
-              <a:t>Computer Vision + NLP report generation</a:t>
+              <a:t>Computer vision plus NLP writes the report</a:t>
             </a:r>
           </a:p>
           <a:p>
@@ -8160,7 +8160,7 @@
                 </a:solidFill>
                 <a:latin typeface="Calibri"/>
               </a:rPr>
-              <a:t>RAG makes LLM output grounded &amp; auditable</a:t>
+              <a:t>RAG keeps the AI's answers grounded and traceable</a:t>
             </a:r>
           </a:p>
           <a:p>
@@ -8691,7 +8691,7 @@
                 </a:solidFill>
                 <a:latin typeface="Calibri"/>
               </a:rPr>
-              <a:t>Upload an X-ray → model returns a generated radiology report</a:t>
+              <a:t>Upload an X-ray and get a generated radiology report</a:t>
             </a:r>
           </a:p>
         </p:txBody>
@@ -8790,7 +8790,7 @@
                 </a:solidFill>
                 <a:latin typeface="Calibri"/>
               </a:rPr>
-              <a:t>Ask "What does cardiomegaly indicate?" → ReAct trace + grounded answer</a:t>
+              <a:t>Ask a clinical question, see the step-by-step reasoning and a grounded answer</a:t>
             </a:r>
           </a:p>
         </p:txBody>
@@ -8889,7 +8889,7 @@
                 </a:solidFill>
                 <a:latin typeface="Calibri"/>
               </a:rPr>
-              <a:t>Add reports, run semantic search, manage the ChromaDB store</a:t>
+              <a:t>Add reports, search by meaning, and manage the vector store</a:t>
             </a:r>
           </a:p>
         </p:txBody>
@@ -8972,7 +8972,7 @@
                 </a:solidFill>
                 <a:latin typeface="Calibri"/>
               </a:rPr>
-              <a:t>System &amp; Telemetry</a:t>
+              <a:t>System and Telemetry</a:t>
             </a:r>
           </a:p>
           <a:p>
@@ -9149,7 +9149,7 @@
                 </a:solidFill>
                 <a:latin typeface="Calibri"/>
               </a:rPr>
-              <a:t>Clinical NLP technology unlocks the 80% of health data trapped in text and images.</a:t>
+              <a:t>Clinical NLP unlocks the 80% of health data trapped in text and images.</a:t>
             </a:r>
           </a:p>
           <a:p>
@@ -9165,7 +9165,7 @@
                 </a:solidFill>
                 <a:latin typeface="Calibri"/>
               </a:rPr>
-              <a:t>Grounded, multimodal, human-in-the-loop AI is the safe path for payment integrity.</a:t>
+              <a:t>Grounded, multimodal AI with people in the loop is the safe path for payment integrity.</a:t>
             </a:r>
           </a:p>
           <a:p>
@@ -9181,7 +9181,7 @@
                 </a:solidFill>
                 <a:latin typeface="Calibri"/>
               </a:rPr>
-              <a:t>The POC proves the full pipeline end to end—model to deployable service.</a:t>
+              <a:t>The POC proves the full pipeline works, from model to deployable service.</a:t>
             </a:r>
           </a:p>
         </p:txBody>

</xml_diff>

<commit_message>
Add HLD architecture + API reference to report, deck, and docs
- Remove em dashes from the Word report
- Add HLD architecture diagram (make_hld.py) used in both documents
- Report: appendix with system architecture + API reference table
- Deck: new System Architecture (HLD) and API-at-a-glance slides (10 total)
- Add docs/api_reference.md

Co-Authored-By: Claude Opus 4.8 <noreply@anthropic.com>
</commit_message>
<xml_diff>
--- a/deliverables/Nitish_Kumar_Presentation.pptx
+++ b/deliverables/Nitish_Kumar_Presentation.pptx
@@ -13,6 +13,8 @@
     <p:sldId id="261" r:id="rId12"/>
     <p:sldId id="262" r:id="rId13"/>
     <p:sldId id="263" r:id="rId14"/>
+    <p:sldId id="264" r:id="rId15"/>
+    <p:sldId id="265" r:id="rId16"/>
   </p:sldIdLst>
   <p:sldSz cx="12191695" cy="6858000" type="screen4x3"/>
   <p:notesSz cx="6858000" cy="9144000"/>
@@ -3639,6 +3641,254 @@
 </p:sld>
 </file>
 
+<file path=ppt/slides/slide10.xml><?xml version="1.0" encoding="utf-8"?>
+<p:sld xmlns:a="http://schemas.openxmlformats.org/drawingml/2006/main" xmlns:p="http://schemas.openxmlformats.org/presentationml/2006/main" xmlns:r="http://schemas.openxmlformats.org/officeDocument/2006/relationships">
+  <p:cSld>
+    <p:spTree>
+      <p:nvGrpSpPr>
+        <p:cNvPr id="1" name=""/>
+        <p:cNvGrpSpPr/>
+        <p:nvPr/>
+      </p:nvGrpSpPr>
+      <p:grpSpPr/>
+      <p:sp>
+        <p:nvSpPr>
+          <p:cNvPr id="2" name="Rectangle 1"/>
+          <p:cNvSpPr/>
+          <p:nvPr/>
+        </p:nvSpPr>
+        <p:spPr>
+          <a:xfrm>
+            <a:off x="0" y="0"/>
+            <a:ext cx="12191695" cy="6858000"/>
+          </a:xfrm>
+          <a:prstGeom prst="rect">
+            <a:avLst/>
+          </a:prstGeom>
+          <a:solidFill>
+            <a:srgbClr val="4B2E83"/>
+          </a:solidFill>
+          <a:ln>
+            <a:noFill/>
+          </a:ln>
+          <a:effectLst/>
+        </p:spPr>
+        <p:style>
+          <a:lnRef idx="1">
+            <a:schemeClr val="accent1"/>
+          </a:lnRef>
+          <a:fillRef idx="3">
+            <a:schemeClr val="accent1"/>
+          </a:fillRef>
+          <a:effectRef idx="2">
+            <a:schemeClr val="accent1"/>
+          </a:effectRef>
+          <a:fontRef idx="minor">
+            <a:schemeClr val="lt1"/>
+          </a:fontRef>
+        </p:style>
+        <p:txBody>
+          <a:bodyPr rtlCol="0" anchor="ctr"/>
+          <a:lstStyle/>
+          <a:p>
+            <a:pPr algn="ctr"/>
+          </a:p>
+        </p:txBody>
+      </p:sp>
+      <p:sp>
+        <p:nvSpPr>
+          <p:cNvPr id="3" name="Rectangle 2"/>
+          <p:cNvSpPr/>
+          <p:nvPr/>
+        </p:nvSpPr>
+        <p:spPr>
+          <a:xfrm>
+            <a:off x="0" y="4754880"/>
+            <a:ext cx="12191695" cy="82296"/>
+          </a:xfrm>
+          <a:prstGeom prst="rect">
+            <a:avLst/>
+          </a:prstGeom>
+          <a:solidFill>
+            <a:srgbClr val="C4007A"/>
+          </a:solidFill>
+          <a:ln>
+            <a:noFill/>
+          </a:ln>
+          <a:effectLst/>
+        </p:spPr>
+        <p:style>
+          <a:lnRef idx="1">
+            <a:schemeClr val="accent1"/>
+          </a:lnRef>
+          <a:fillRef idx="3">
+            <a:schemeClr val="accent1"/>
+          </a:fillRef>
+          <a:effectRef idx="2">
+            <a:schemeClr val="accent1"/>
+          </a:effectRef>
+          <a:fontRef idx="minor">
+            <a:schemeClr val="lt1"/>
+          </a:fontRef>
+        </p:style>
+        <p:txBody>
+          <a:bodyPr rtlCol="0" anchor="ctr"/>
+          <a:lstStyle/>
+          <a:p>
+            <a:pPr algn="ctr"/>
+          </a:p>
+        </p:txBody>
+      </p:sp>
+      <p:sp>
+        <p:nvSpPr>
+          <p:cNvPr id="4" name="TextBox 3"/>
+          <p:cNvSpPr txBox="1"/>
+          <p:nvPr/>
+        </p:nvSpPr>
+        <p:spPr>
+          <a:xfrm>
+            <a:off x="822960" y="1463040"/>
+            <a:ext cx="10515600" cy="2743200"/>
+          </a:xfrm>
+          <a:prstGeom prst="rect">
+            <a:avLst/>
+          </a:prstGeom>
+          <a:noFill/>
+        </p:spPr>
+        <p:txBody>
+          <a:bodyPr wrap="square" anchor="t">
+            <a:spAutoFit/>
+          </a:bodyPr>
+          <a:lstStyle/>
+          <a:p>
+            <a:pPr algn="l">
+              <a:spcAft>
+                <a:spcPts val="1800"/>
+              </a:spcAft>
+            </a:pPr>
+            <a:r>
+              <a:rPr sz="3400" b="1" i="0">
+                <a:solidFill>
+                  <a:srgbClr val="FFFFFF"/>
+                </a:solidFill>
+                <a:latin typeface="Calibri"/>
+              </a:rPr>
+              <a:t>Key Takeaways</a:t>
+            </a:r>
+          </a:p>
+          <a:p>
+            <a:pPr algn="l">
+              <a:spcAft>
+                <a:spcPts val="1200"/>
+              </a:spcAft>
+            </a:pPr>
+            <a:r>
+              <a:rPr sz="1800" b="0" i="0">
+                <a:solidFill>
+                  <a:srgbClr val="E8DEF6"/>
+                </a:solidFill>
+                <a:latin typeface="Calibri"/>
+              </a:rPr>
+              <a:t>Clinical NLP unlocks the 80% of health data trapped in text and images.</a:t>
+            </a:r>
+          </a:p>
+          <a:p>
+            <a:pPr algn="l">
+              <a:spcAft>
+                <a:spcPts val="1200"/>
+              </a:spcAft>
+            </a:pPr>
+            <a:r>
+              <a:rPr sz="1800" b="0" i="0">
+                <a:solidFill>
+                  <a:srgbClr val="E8DEF6"/>
+                </a:solidFill>
+                <a:latin typeface="Calibri"/>
+              </a:rPr>
+              <a:t>Grounded, multimodal AI with people in the loop is the safe path for payment integrity.</a:t>
+            </a:r>
+          </a:p>
+          <a:p>
+            <a:pPr algn="l">
+              <a:spcAft>
+                <a:spcPts val="1200"/>
+              </a:spcAft>
+            </a:pPr>
+            <a:r>
+              <a:rPr sz="1800" b="0" i="0">
+                <a:solidFill>
+                  <a:srgbClr val="E8DEF6"/>
+                </a:solidFill>
+                <a:latin typeface="Calibri"/>
+              </a:rPr>
+              <a:t>The POC proves the full pipeline works, from model to deployable service.</a:t>
+            </a:r>
+          </a:p>
+        </p:txBody>
+      </p:sp>
+      <p:sp>
+        <p:nvSpPr>
+          <p:cNvPr id="5" name="TextBox 4"/>
+          <p:cNvSpPr txBox="1"/>
+          <p:nvPr/>
+        </p:nvSpPr>
+        <p:spPr>
+          <a:xfrm>
+            <a:off x="822960" y="5029200"/>
+            <a:ext cx="10058400" cy="1097280"/>
+          </a:xfrm>
+          <a:prstGeom prst="rect">
+            <a:avLst/>
+          </a:prstGeom>
+          <a:noFill/>
+        </p:spPr>
+        <p:txBody>
+          <a:bodyPr wrap="square" anchor="t">
+            <a:spAutoFit/>
+          </a:bodyPr>
+          <a:lstStyle/>
+          <a:p>
+            <a:pPr algn="l">
+              <a:spcAft>
+                <a:spcPts val="200"/>
+              </a:spcAft>
+            </a:pPr>
+            <a:r>
+              <a:rPr sz="2400" b="1" i="0">
+                <a:solidFill>
+                  <a:srgbClr val="FFFFFF"/>
+                </a:solidFill>
+                <a:latin typeface="Calibri"/>
+              </a:rPr>
+              <a:t>Thank You</a:t>
+            </a:r>
+          </a:p>
+          <a:p>
+            <a:pPr algn="l">
+              <a:spcAft>
+                <a:spcPts val="0"/>
+              </a:spcAft>
+            </a:pPr>
+            <a:r>
+              <a:rPr sz="1300" b="0" i="0">
+                <a:solidFill>
+                  <a:srgbClr val="D9C7F0"/>
+                </a:solidFill>
+                <a:latin typeface="Calibri"/>
+              </a:rPr>
+              <a:t>Nitish Kumar  ·  San Jose State University  ·  nitish.kumar@sjsu.edu</a:t>
+            </a:r>
+          </a:p>
+        </p:txBody>
+      </p:sp>
+    </p:spTree>
+  </p:cSld>
+  <p:clrMapOvr>
+    <a:masterClrMapping/>
+  </p:clrMapOvr>
+</p:sld>
+</file>
+
 <file path=ppt/slides/slide2.xml><?xml version="1.0" encoding="utf-8"?>
 <p:sld xmlns:a="http://schemas.openxmlformats.org/drawingml/2006/main" xmlns:p="http://schemas.openxmlformats.org/presentationml/2006/main" xmlns:r="http://schemas.openxmlformats.org/officeDocument/2006/relationships">
   <p:cSld>
@@ -8498,7 +8748,7 @@
                 </a:solidFill>
                 <a:latin typeface="Calibri"/>
               </a:rPr>
-              <a:t>LIVE DEMO</a:t>
+              <a:t>HOW IT WORKS</a:t>
             </a:r>
           </a:p>
           <a:p>
@@ -8514,7 +8764,7 @@
                 </a:solidFill>
                 <a:latin typeface="Calibri"/>
               </a:rPr>
-              <a:t>What You'll See in the Screenshare</a:t>
+              <a:t>System Architecture (High-Level Design)</a:t>
             </a:r>
           </a:p>
         </p:txBody>
@@ -8597,50 +8847,30 @@
           </a:p>
         </p:txBody>
       </p:sp>
-      <p:sp>
-        <p:nvSpPr>
-          <p:cNvPr id="7" name="Oval 6"/>
-          <p:cNvSpPr/>
-          <p:nvPr/>
-        </p:nvSpPr>
-        <p:spPr>
-          <a:xfrm>
-            <a:off x="640080" y="1755648"/>
-            <a:ext cx="201168" cy="201168"/>
-          </a:xfrm>
-          <a:prstGeom prst="ellipse">
-            <a:avLst/>
-          </a:prstGeom>
-          <a:solidFill>
-            <a:srgbClr val="C4007A"/>
-          </a:solidFill>
-          <a:ln>
-            <a:noFill/>
-          </a:ln>
-          <a:effectLst/>
-        </p:spPr>
-        <p:style>
-          <a:lnRef idx="1">
-            <a:schemeClr val="accent1"/>
-          </a:lnRef>
-          <a:fillRef idx="3">
-            <a:schemeClr val="accent1"/>
-          </a:fillRef>
-          <a:effectRef idx="2">
-            <a:schemeClr val="accent1"/>
-          </a:effectRef>
-          <a:fontRef idx="minor">
-            <a:schemeClr val="lt1"/>
-          </a:fontRef>
-        </p:style>
-        <p:txBody>
-          <a:bodyPr rtlCol="0" anchor="ctr"/>
-          <a:lstStyle/>
-          <a:p>
-            <a:pPr algn="ctr"/>
-          </a:p>
-        </p:txBody>
-      </p:sp>
+      <p:pic>
+        <p:nvPicPr>
+          <p:cNvPr id="7" name="Picture 6" descr="hld_architecture.png"/>
+          <p:cNvPicPr>
+            <a:picLocks noChangeAspect="1"/>
+          </p:cNvPicPr>
+          <p:nvPr/>
+        </p:nvPicPr>
+        <p:blipFill>
+          <a:blip r:embed="rId2"/>
+          <a:stretch>
+            <a:fillRect/>
+          </a:stretch>
+        </p:blipFill>
+        <p:spPr>
+          <a:xfrm>
+            <a:off x="1888320" y="1371600"/>
+            <a:ext cx="8267429" cy="4526280"/>
+          </a:xfrm>
+          <a:prstGeom prst="rect">
+            <a:avLst/>
+          </a:prstGeom>
+        </p:spPr>
+      </p:pic>
       <p:sp>
         <p:nvSpPr>
           <p:cNvPr id="8" name="TextBox 7"/>
@@ -8649,8 +8879,8 @@
         </p:nvSpPr>
         <p:spPr>
           <a:xfrm>
-            <a:off x="1051560" y="1645920"/>
-            <a:ext cx="10607040" cy="1005840"/>
+            <a:off x="548640" y="6080760"/>
+            <a:ext cx="11064240" cy="320040"/>
           </a:xfrm>
           <a:prstGeom prst="rect">
             <a:avLst/>
@@ -8663,332 +8893,19 @@
           </a:bodyPr>
           <a:lstStyle/>
           <a:p>
-            <a:pPr algn="l">
-              <a:spcAft>
-                <a:spcPts val="200"/>
-              </a:spcAft>
-            </a:pPr>
-            <a:r>
-              <a:rPr sz="1600" b="1" i="0">
-                <a:solidFill>
-                  <a:srgbClr val="C4007A"/>
-                </a:solidFill>
-                <a:latin typeface="Calibri"/>
-              </a:rPr>
-              <a:t>Report Generation</a:t>
-            </a:r>
-          </a:p>
-          <a:p>
-            <a:pPr algn="l">
-              <a:spcAft>
-                <a:spcPts val="0"/>
-              </a:spcAft>
-            </a:pPr>
-            <a:r>
-              <a:rPr sz="1300" b="0" i="0">
-                <a:solidFill>
-                  <a:srgbClr val="222222"/>
-                </a:solidFill>
-                <a:latin typeface="Calibri"/>
-              </a:rPr>
-              <a:t>Upload an X-ray and get a generated radiology report</a:t>
-            </a:r>
-          </a:p>
-        </p:txBody>
-      </p:sp>
-      <p:sp>
-        <p:nvSpPr>
-          <p:cNvPr id="9" name="Oval 8"/>
-          <p:cNvSpPr/>
-          <p:nvPr/>
-        </p:nvSpPr>
-        <p:spPr>
-          <a:xfrm>
-            <a:off x="640080" y="2834640"/>
-            <a:ext cx="201168" cy="201168"/>
-          </a:xfrm>
-          <a:prstGeom prst="ellipse">
-            <a:avLst/>
-          </a:prstGeom>
-          <a:solidFill>
-            <a:srgbClr val="4B2E83"/>
-          </a:solidFill>
-          <a:ln>
-            <a:noFill/>
-          </a:ln>
-          <a:effectLst/>
-        </p:spPr>
-        <p:style>
-          <a:lnRef idx="1">
-            <a:schemeClr val="accent1"/>
-          </a:lnRef>
-          <a:fillRef idx="3">
-            <a:schemeClr val="accent1"/>
-          </a:fillRef>
-          <a:effectRef idx="2">
-            <a:schemeClr val="accent1"/>
-          </a:effectRef>
-          <a:fontRef idx="minor">
-            <a:schemeClr val="lt1"/>
-          </a:fontRef>
-        </p:style>
-        <p:txBody>
-          <a:bodyPr rtlCol="0" anchor="ctr"/>
-          <a:lstStyle/>
-          <a:p>
-            <a:pPr algn="ctr"/>
-          </a:p>
-        </p:txBody>
-      </p:sp>
-      <p:sp>
-        <p:nvSpPr>
-          <p:cNvPr id="10" name="TextBox 9"/>
-          <p:cNvSpPr txBox="1"/>
-          <p:nvPr/>
-        </p:nvSpPr>
-        <p:spPr>
-          <a:xfrm>
-            <a:off x="1051560" y="2724912"/>
-            <a:ext cx="10607040" cy="1005840"/>
-          </a:xfrm>
-          <a:prstGeom prst="rect">
-            <a:avLst/>
-          </a:prstGeom>
-          <a:noFill/>
-        </p:spPr>
-        <p:txBody>
-          <a:bodyPr wrap="square" anchor="t">
-            <a:spAutoFit/>
-          </a:bodyPr>
-          <a:lstStyle/>
-          <a:p>
-            <a:pPr algn="l">
-              <a:spcAft>
-                <a:spcPts val="200"/>
-              </a:spcAft>
-            </a:pPr>
-            <a:r>
-              <a:rPr sz="1600" b="1" i="0">
-                <a:solidFill>
-                  <a:srgbClr val="4B2E83"/>
-                </a:solidFill>
-                <a:latin typeface="Calibri"/>
-              </a:rPr>
-              <a:t>Clinical Agent</a:t>
-            </a:r>
-          </a:p>
-          <a:p>
-            <a:pPr algn="l">
-              <a:spcAft>
-                <a:spcPts val="0"/>
-              </a:spcAft>
-            </a:pPr>
-            <a:r>
-              <a:rPr sz="1300" b="0" i="0">
-                <a:solidFill>
-                  <a:srgbClr val="222222"/>
-                </a:solidFill>
-                <a:latin typeface="Calibri"/>
-              </a:rPr>
-              <a:t>Ask a clinical question, see the step-by-step reasoning and a grounded answer</a:t>
-            </a:r>
-          </a:p>
-        </p:txBody>
-      </p:sp>
-      <p:sp>
-        <p:nvSpPr>
-          <p:cNvPr id="11" name="Oval 10"/>
-          <p:cNvSpPr/>
-          <p:nvPr/>
-        </p:nvSpPr>
-        <p:spPr>
-          <a:xfrm>
-            <a:off x="640080" y="3913632"/>
-            <a:ext cx="201168" cy="201168"/>
-          </a:xfrm>
-          <a:prstGeom prst="ellipse">
-            <a:avLst/>
-          </a:prstGeom>
-          <a:solidFill>
-            <a:srgbClr val="009E8F"/>
-          </a:solidFill>
-          <a:ln>
-            <a:noFill/>
-          </a:ln>
-          <a:effectLst/>
-        </p:spPr>
-        <p:style>
-          <a:lnRef idx="1">
-            <a:schemeClr val="accent1"/>
-          </a:lnRef>
-          <a:fillRef idx="3">
-            <a:schemeClr val="accent1"/>
-          </a:fillRef>
-          <a:effectRef idx="2">
-            <a:schemeClr val="accent1"/>
-          </a:effectRef>
-          <a:fontRef idx="minor">
-            <a:schemeClr val="lt1"/>
-          </a:fontRef>
-        </p:style>
-        <p:txBody>
-          <a:bodyPr rtlCol="0" anchor="ctr"/>
-          <a:lstStyle/>
-          <a:p>
-            <a:pPr algn="ctr"/>
-          </a:p>
-        </p:txBody>
-      </p:sp>
-      <p:sp>
-        <p:nvSpPr>
-          <p:cNvPr id="12" name="TextBox 11"/>
-          <p:cNvSpPr txBox="1"/>
-          <p:nvPr/>
-        </p:nvSpPr>
-        <p:spPr>
-          <a:xfrm>
-            <a:off x="1051560" y="3803904"/>
-            <a:ext cx="10607040" cy="1005840"/>
-          </a:xfrm>
-          <a:prstGeom prst="rect">
-            <a:avLst/>
-          </a:prstGeom>
-          <a:noFill/>
-        </p:spPr>
-        <p:txBody>
-          <a:bodyPr wrap="square" anchor="t">
-            <a:spAutoFit/>
-          </a:bodyPr>
-          <a:lstStyle/>
-          <a:p>
-            <a:pPr algn="l">
-              <a:spcAft>
-                <a:spcPts val="200"/>
-              </a:spcAft>
-            </a:pPr>
-            <a:r>
-              <a:rPr sz="1600" b="1" i="0">
-                <a:solidFill>
-                  <a:srgbClr val="009E8F"/>
-                </a:solidFill>
-                <a:latin typeface="Calibri"/>
-              </a:rPr>
-              <a:t>Knowledge Base</a:t>
-            </a:r>
-          </a:p>
-          <a:p>
-            <a:pPr algn="l">
-              <a:spcAft>
-                <a:spcPts val="0"/>
-              </a:spcAft>
-            </a:pPr>
-            <a:r>
-              <a:rPr sz="1300" b="0" i="0">
-                <a:solidFill>
-                  <a:srgbClr val="222222"/>
-                </a:solidFill>
-                <a:latin typeface="Calibri"/>
-              </a:rPr>
-              <a:t>Add reports, search by meaning, and manage the vector store</a:t>
-            </a:r>
-          </a:p>
-        </p:txBody>
-      </p:sp>
-      <p:sp>
-        <p:nvSpPr>
-          <p:cNvPr id="13" name="Oval 12"/>
-          <p:cNvSpPr/>
-          <p:nvPr/>
-        </p:nvSpPr>
-        <p:spPr>
-          <a:xfrm>
-            <a:off x="640080" y="4992624"/>
-            <a:ext cx="201168" cy="201168"/>
-          </a:xfrm>
-          <a:prstGeom prst="ellipse">
-            <a:avLst/>
-          </a:prstGeom>
-          <a:solidFill>
-            <a:srgbClr val="E07A00"/>
-          </a:solidFill>
-          <a:ln>
-            <a:noFill/>
-          </a:ln>
-          <a:effectLst/>
-        </p:spPr>
-        <p:style>
-          <a:lnRef idx="1">
-            <a:schemeClr val="accent1"/>
-          </a:lnRef>
-          <a:fillRef idx="3">
-            <a:schemeClr val="accent1"/>
-          </a:fillRef>
-          <a:effectRef idx="2">
-            <a:schemeClr val="accent1"/>
-          </a:effectRef>
-          <a:fontRef idx="minor">
-            <a:schemeClr val="lt1"/>
-          </a:fontRef>
-        </p:style>
-        <p:txBody>
-          <a:bodyPr rtlCol="0" anchor="ctr"/>
-          <a:lstStyle/>
-          <a:p>
-            <a:pPr algn="ctr"/>
-          </a:p>
-        </p:txBody>
-      </p:sp>
-      <p:sp>
-        <p:nvSpPr>
-          <p:cNvPr id="14" name="TextBox 13"/>
-          <p:cNvSpPr txBox="1"/>
-          <p:nvPr/>
-        </p:nvSpPr>
-        <p:spPr>
-          <a:xfrm>
-            <a:off x="1051560" y="4882896"/>
-            <a:ext cx="10607040" cy="1005840"/>
-          </a:xfrm>
-          <a:prstGeom prst="rect">
-            <a:avLst/>
-          </a:prstGeom>
-          <a:noFill/>
-        </p:spPr>
-        <p:txBody>
-          <a:bodyPr wrap="square" anchor="t">
-            <a:spAutoFit/>
-          </a:bodyPr>
-          <a:lstStyle/>
-          <a:p>
-            <a:pPr algn="l">
-              <a:spcAft>
-                <a:spcPts val="200"/>
-              </a:spcAft>
-            </a:pPr>
-            <a:r>
-              <a:rPr sz="1600" b="1" i="0">
-                <a:solidFill>
-                  <a:srgbClr val="E07A00"/>
-                </a:solidFill>
-                <a:latin typeface="Calibri"/>
-              </a:rPr>
-              <a:t>System and Telemetry</a:t>
-            </a:r>
-          </a:p>
-          <a:p>
-            <a:pPr algn="l">
-              <a:spcAft>
-                <a:spcPts val="0"/>
-              </a:spcAft>
-            </a:pPr>
-            <a:r>
-              <a:rPr sz="1300" b="0" i="0">
-                <a:solidFill>
-                  <a:srgbClr val="222222"/>
-                </a:solidFill>
-                <a:latin typeface="Calibri"/>
-              </a:rPr>
-              <a:t>Live health, Prometheus metrics, OpenTelemetry status</a:t>
+            <a:pPr algn="ctr">
+              <a:spcAft>
+                <a:spcPts val="600"/>
+              </a:spcAft>
+            </a:pPr>
+            <a:r>
+              <a:rPr sz="1100" b="0" i="0">
+                <a:solidFill>
+                  <a:srgbClr val="5A5A5A"/>
+                </a:solidFill>
+                <a:latin typeface="Calibri"/>
+              </a:rPr>
+              <a:t>Four layers: clients to FastAPI to services (model, DICOM, RAG, async) to data, with observability and delivery across the whole stack.</a:t>
             </a:r>
           </a:p>
         </p:txBody>
@@ -9020,7 +8937,7 @@
         <p:spPr>
           <a:xfrm>
             <a:off x="0" y="0"/>
-            <a:ext cx="12191695" cy="6858000"/>
+            <a:ext cx="12191695" cy="1143000"/>
           </a:xfrm>
           <a:prstGeom prst="rect">
             <a:avLst/>
@@ -9063,8 +8980,8 @@
         </p:nvSpPr>
         <p:spPr>
           <a:xfrm>
-            <a:off x="0" y="4754880"/>
-            <a:ext cx="12191695" cy="82296"/>
+            <a:off x="0" y="1143000"/>
+            <a:ext cx="12191695" cy="54864"/>
           </a:xfrm>
           <a:prstGeom prst="rect">
             <a:avLst/>
@@ -9107,8 +9024,8 @@
         </p:nvSpPr>
         <p:spPr>
           <a:xfrm>
-            <a:off x="822960" y="1463040"/>
-            <a:ext cx="10515600" cy="2743200"/>
+            <a:off x="548640" y="164592"/>
+            <a:ext cx="10972800" cy="914400"/>
           </a:xfrm>
           <a:prstGeom prst="rect">
             <a:avLst/>
@@ -9123,65 +9040,33 @@
           <a:p>
             <a:pPr algn="l">
               <a:spcAft>
-                <a:spcPts val="1800"/>
-              </a:spcAft>
-            </a:pPr>
-            <a:r>
-              <a:rPr sz="3400" b="1" i="0">
+                <a:spcPts val="200"/>
+              </a:spcAft>
+            </a:pPr>
+            <a:r>
+              <a:rPr sz="1200" b="1" i="0">
+                <a:solidFill>
+                  <a:srgbClr val="D9C7F0"/>
+                </a:solidFill>
+                <a:latin typeface="Calibri"/>
+              </a:rPr>
+              <a:t>INTERFACE</a:t>
+            </a:r>
+          </a:p>
+          <a:p>
+            <a:pPr algn="l">
+              <a:spcAft>
+                <a:spcPts val="0"/>
+              </a:spcAft>
+            </a:pPr>
+            <a:r>
+              <a:rPr sz="2600" b="1" i="0">
                 <a:solidFill>
                   <a:srgbClr val="FFFFFF"/>
                 </a:solidFill>
                 <a:latin typeface="Calibri"/>
               </a:rPr>
-              <a:t>Key Takeaways</a:t>
-            </a:r>
-          </a:p>
-          <a:p>
-            <a:pPr algn="l">
-              <a:spcAft>
-                <a:spcPts val="1200"/>
-              </a:spcAft>
-            </a:pPr>
-            <a:r>
-              <a:rPr sz="1800" b="0" i="0">
-                <a:solidFill>
-                  <a:srgbClr val="E8DEF6"/>
-                </a:solidFill>
-                <a:latin typeface="Calibri"/>
-              </a:rPr>
-              <a:t>Clinical NLP unlocks the 80% of health data trapped in text and images.</a:t>
-            </a:r>
-          </a:p>
-          <a:p>
-            <a:pPr algn="l">
-              <a:spcAft>
-                <a:spcPts val="1200"/>
-              </a:spcAft>
-            </a:pPr>
-            <a:r>
-              <a:rPr sz="1800" b="0" i="0">
-                <a:solidFill>
-                  <a:srgbClr val="E8DEF6"/>
-                </a:solidFill>
-                <a:latin typeface="Calibri"/>
-              </a:rPr>
-              <a:t>Grounded, multimodal AI with people in the loop is the safe path for payment integrity.</a:t>
-            </a:r>
-          </a:p>
-          <a:p>
-            <a:pPr algn="l">
-              <a:spcAft>
-                <a:spcPts val="1200"/>
-              </a:spcAft>
-            </a:pPr>
-            <a:r>
-              <a:rPr sz="1800" b="0" i="0">
-                <a:solidFill>
-                  <a:srgbClr val="E8DEF6"/>
-                </a:solidFill>
-                <a:latin typeface="Calibri"/>
-              </a:rPr>
-              <a:t>The POC proves the full pipeline works, from model to deployable service.</a:t>
+              <a:t>The API at a Glance</a:t>
             </a:r>
           </a:p>
         </p:txBody>
@@ -9194,8 +9079,8 @@
         </p:nvSpPr>
         <p:spPr>
           <a:xfrm>
-            <a:off x="822960" y="5029200"/>
-            <a:ext cx="10058400" cy="1097280"/>
+            <a:off x="365760" y="6446520"/>
+            <a:ext cx="8229600" cy="320040"/>
           </a:xfrm>
           <a:prstGeom prst="rect">
             <a:avLst/>
@@ -9210,33 +9095,1472 @@
           <a:p>
             <a:pPr algn="l">
               <a:spcAft>
+                <a:spcPts val="600"/>
+              </a:spcAft>
+            </a:pPr>
+            <a:r>
+              <a:rPr sz="900" b="0" i="0">
+                <a:solidFill>
+                  <a:srgbClr val="5A5A5A"/>
+                </a:solidFill>
+                <a:latin typeface="Calibri"/>
+              </a:rPr>
+              <a:t>Cotiviti Intern Assessment  ·  Nitish Kumar  ·  San Jose State University</a:t>
+            </a:r>
+          </a:p>
+        </p:txBody>
+      </p:sp>
+      <p:sp>
+        <p:nvSpPr>
+          <p:cNvPr id="6" name="TextBox 5"/>
+          <p:cNvSpPr txBox="1"/>
+          <p:nvPr/>
+        </p:nvSpPr>
+        <p:spPr>
+          <a:xfrm>
+            <a:off x="11155680" y="6446520"/>
+            <a:ext cx="822960" cy="320040"/>
+          </a:xfrm>
+          <a:prstGeom prst="rect">
+            <a:avLst/>
+          </a:prstGeom>
+          <a:noFill/>
+        </p:spPr>
+        <p:txBody>
+          <a:bodyPr wrap="square" anchor="t">
+            <a:spAutoFit/>
+          </a:bodyPr>
+          <a:lstStyle/>
+          <a:p>
+            <a:pPr algn="r">
+              <a:spcAft>
+                <a:spcPts val="600"/>
+              </a:spcAft>
+            </a:pPr>
+            <a:r>
+              <a:rPr sz="900" b="0" i="0">
+                <a:solidFill>
+                  <a:srgbClr val="5A5A5A"/>
+                </a:solidFill>
+                <a:latin typeface="Calibri"/>
+              </a:rPr>
+              <a:t>8</a:t>
+            </a:r>
+          </a:p>
+        </p:txBody>
+      </p:sp>
+      <p:sp>
+        <p:nvSpPr>
+          <p:cNvPr id="7" name="TextBox 6"/>
+          <p:cNvSpPr txBox="1"/>
+          <p:nvPr/>
+        </p:nvSpPr>
+        <p:spPr>
+          <a:xfrm>
+            <a:off x="548640" y="1371600"/>
+            <a:ext cx="11064240" cy="548640"/>
+          </a:xfrm>
+          <a:prstGeom prst="rect">
+            <a:avLst/>
+          </a:prstGeom>
+          <a:noFill/>
+        </p:spPr>
+        <p:txBody>
+          <a:bodyPr wrap="square" anchor="t">
+            <a:spAutoFit/>
+          </a:bodyPr>
+          <a:lstStyle/>
+          <a:p>
+            <a:pPr algn="l">
+              <a:spcAft>
+                <a:spcPts val="600"/>
+              </a:spcAft>
+            </a:pPr>
+            <a:r>
+              <a:rPr sz="1400" b="0" i="0">
+                <a:solidFill>
+                  <a:srgbClr val="5A5A5A"/>
+                </a:solidFill>
+                <a:latin typeface="Calibri"/>
+              </a:rPr>
+              <a:t>A REST API built with FastAPI. Full interactive docs are auto-generated at /docs (Swagger).</a:t>
+            </a:r>
+          </a:p>
+        </p:txBody>
+      </p:sp>
+      <p:sp>
+        <p:nvSpPr>
+          <p:cNvPr id="8" name="Rectangle 7"/>
+          <p:cNvSpPr/>
+          <p:nvPr/>
+        </p:nvSpPr>
+        <p:spPr>
+          <a:xfrm>
+            <a:off x="548640" y="2057400"/>
+            <a:ext cx="3703320" cy="502920"/>
+          </a:xfrm>
+          <a:prstGeom prst="rect">
+            <a:avLst/>
+          </a:prstGeom>
+          <a:solidFill>
+            <a:srgbClr val="4B2E83"/>
+          </a:solidFill>
+          <a:ln>
+            <a:noFill/>
+          </a:ln>
+          <a:effectLst/>
+        </p:spPr>
+        <p:style>
+          <a:lnRef idx="1">
+            <a:schemeClr val="accent1"/>
+          </a:lnRef>
+          <a:fillRef idx="3">
+            <a:schemeClr val="accent1"/>
+          </a:fillRef>
+          <a:effectRef idx="2">
+            <a:schemeClr val="accent1"/>
+          </a:effectRef>
+          <a:fontRef idx="minor">
+            <a:schemeClr val="lt1"/>
+          </a:fontRef>
+        </p:style>
+        <p:txBody>
+          <a:bodyPr rtlCol="0" anchor="ctr"/>
+          <a:lstStyle/>
+          <a:p>
+            <a:pPr algn="ctr"/>
+          </a:p>
+        </p:txBody>
+      </p:sp>
+      <p:sp>
+        <p:nvSpPr>
+          <p:cNvPr id="9" name="TextBox 8"/>
+          <p:cNvSpPr txBox="1"/>
+          <p:nvPr/>
+        </p:nvSpPr>
+        <p:spPr>
+          <a:xfrm>
+            <a:off x="731520" y="2084831"/>
+            <a:ext cx="3429000" cy="457200"/>
+          </a:xfrm>
+          <a:prstGeom prst="rect">
+            <a:avLst/>
+          </a:prstGeom>
+          <a:noFill/>
+        </p:spPr>
+        <p:txBody>
+          <a:bodyPr wrap="square" anchor="ctr">
+            <a:spAutoFit/>
+          </a:bodyPr>
+          <a:lstStyle/>
+          <a:p>
+            <a:pPr algn="l">
+              <a:spcAft>
+                <a:spcPts val="600"/>
+              </a:spcAft>
+            </a:pPr>
+            <a:r>
+              <a:rPr sz="1300" b="1" i="0">
+                <a:solidFill>
+                  <a:srgbClr val="FFFFFF"/>
+                </a:solidFill>
+                <a:latin typeface="Calibri"/>
+              </a:rPr>
+              <a:t>SYSTEM</a:t>
+            </a:r>
+          </a:p>
+        </p:txBody>
+      </p:sp>
+      <p:sp>
+        <p:nvSpPr>
+          <p:cNvPr id="10" name="Rectangle 9"/>
+          <p:cNvSpPr/>
+          <p:nvPr/>
+        </p:nvSpPr>
+        <p:spPr>
+          <a:xfrm>
+            <a:off x="548640" y="2560320"/>
+            <a:ext cx="3703320" cy="3383280"/>
+          </a:xfrm>
+          <a:prstGeom prst="rect">
+            <a:avLst/>
+          </a:prstGeom>
+          <a:solidFill>
+            <a:srgbClr val="FFFFFF"/>
+          </a:solidFill>
+          <a:ln w="12700">
+            <a:solidFill>
+              <a:srgbClr val="E2DDEE"/>
+            </a:solidFill>
+          </a:ln>
+          <a:effectLst/>
+        </p:spPr>
+        <p:style>
+          <a:lnRef idx="1">
+            <a:schemeClr val="accent1"/>
+          </a:lnRef>
+          <a:fillRef idx="3">
+            <a:schemeClr val="accent1"/>
+          </a:fillRef>
+          <a:effectRef idx="2">
+            <a:schemeClr val="accent1"/>
+          </a:effectRef>
+          <a:fontRef idx="minor">
+            <a:schemeClr val="lt1"/>
+          </a:fontRef>
+        </p:style>
+        <p:txBody>
+          <a:bodyPr rtlCol="0" anchor="ctr"/>
+          <a:lstStyle/>
+          <a:p>
+            <a:pPr algn="ctr"/>
+          </a:p>
+        </p:txBody>
+      </p:sp>
+      <p:sp>
+        <p:nvSpPr>
+          <p:cNvPr id="11" name="TextBox 10"/>
+          <p:cNvSpPr txBox="1"/>
+          <p:nvPr/>
+        </p:nvSpPr>
+        <p:spPr>
+          <a:xfrm>
+            <a:off x="749808" y="2697480"/>
+            <a:ext cx="3337560" cy="3200400"/>
+          </a:xfrm>
+          <a:prstGeom prst="rect">
+            <a:avLst/>
+          </a:prstGeom>
+          <a:noFill/>
+        </p:spPr>
+        <p:txBody>
+          <a:bodyPr wrap="square" anchor="t">
+            <a:spAutoFit/>
+          </a:bodyPr>
+          <a:lstStyle/>
+          <a:p>
+            <a:pPr>
+              <a:spcAft>
+                <a:spcPts val="900"/>
+              </a:spcAft>
+            </a:pPr>
+            <a:r>
+              <a:rPr sz="1150" b="1" i="0">
+                <a:solidFill>
+                  <a:srgbClr val="4B2E83"/>
+                </a:solidFill>
+                <a:latin typeface="Consolas"/>
+              </a:rPr>
+              <a:t>GET  /health</a:t>
+            </a:r>
+            <a:r>
+              <a:rPr sz="1050" b="0" i="0">
+                <a:solidFill>
+                  <a:srgbClr val="222222"/>
+                </a:solidFill>
+                <a:latin typeface="Calibri"/>
+              </a:rPr>
+              <a:t>
+liveness and model-loaded status</a:t>
+            </a:r>
+          </a:p>
+          <a:p>
+            <a:pPr>
+              <a:spcAft>
+                <a:spcPts val="900"/>
+              </a:spcAft>
+            </a:pPr>
+            <a:r>
+              <a:rPr sz="1150" b="1" i="0">
+                <a:solidFill>
+                  <a:srgbClr val="4B2E83"/>
+                </a:solidFill>
+                <a:latin typeface="Consolas"/>
+              </a:rPr>
+              <a:t>GET  /metadata</a:t>
+            </a:r>
+            <a:r>
+              <a:rPr sz="1050" b="0" i="0">
+                <a:solidFill>
+                  <a:srgbClr val="222222"/>
+                </a:solidFill>
+                <a:latin typeface="Calibri"/>
+              </a:rPr>
+              <a:t>
+model architecture details</a:t>
+            </a:r>
+          </a:p>
+          <a:p>
+            <a:pPr>
+              <a:spcAft>
+                <a:spcPts val="900"/>
+              </a:spcAft>
+            </a:pPr>
+            <a:r>
+              <a:rPr sz="1150" b="1" i="0">
+                <a:solidFill>
+                  <a:srgbClr val="4B2E83"/>
+                </a:solidFill>
+                <a:latin typeface="Consolas"/>
+              </a:rPr>
+              <a:t>GET  /metrics</a:t>
+            </a:r>
+            <a:r>
+              <a:rPr sz="1050" b="0" i="0">
+                <a:solidFill>
+                  <a:srgbClr val="222222"/>
+                </a:solidFill>
+                <a:latin typeface="Calibri"/>
+              </a:rPr>
+              <a:t>
+Prometheus metrics</a:t>
+            </a:r>
+          </a:p>
+        </p:txBody>
+      </p:sp>
+      <p:sp>
+        <p:nvSpPr>
+          <p:cNvPr id="12" name="Rectangle 11"/>
+          <p:cNvSpPr/>
+          <p:nvPr/>
+        </p:nvSpPr>
+        <p:spPr>
+          <a:xfrm>
+            <a:off x="4370832" y="2057400"/>
+            <a:ext cx="3703320" cy="502920"/>
+          </a:xfrm>
+          <a:prstGeom prst="rect">
+            <a:avLst/>
+          </a:prstGeom>
+          <a:solidFill>
+            <a:srgbClr val="C4007A"/>
+          </a:solidFill>
+          <a:ln>
+            <a:noFill/>
+          </a:ln>
+          <a:effectLst/>
+        </p:spPr>
+        <p:style>
+          <a:lnRef idx="1">
+            <a:schemeClr val="accent1"/>
+          </a:lnRef>
+          <a:fillRef idx="3">
+            <a:schemeClr val="accent1"/>
+          </a:fillRef>
+          <a:effectRef idx="2">
+            <a:schemeClr val="accent1"/>
+          </a:effectRef>
+          <a:fontRef idx="minor">
+            <a:schemeClr val="lt1"/>
+          </a:fontRef>
+        </p:style>
+        <p:txBody>
+          <a:bodyPr rtlCol="0" anchor="ctr"/>
+          <a:lstStyle/>
+          <a:p>
+            <a:pPr algn="ctr"/>
+          </a:p>
+        </p:txBody>
+      </p:sp>
+      <p:sp>
+        <p:nvSpPr>
+          <p:cNvPr id="13" name="TextBox 12"/>
+          <p:cNvSpPr txBox="1"/>
+          <p:nvPr/>
+        </p:nvSpPr>
+        <p:spPr>
+          <a:xfrm>
+            <a:off x="4553712" y="2084831"/>
+            <a:ext cx="3429000" cy="457200"/>
+          </a:xfrm>
+          <a:prstGeom prst="rect">
+            <a:avLst/>
+          </a:prstGeom>
+          <a:noFill/>
+        </p:spPr>
+        <p:txBody>
+          <a:bodyPr wrap="square" anchor="ctr">
+            <a:spAutoFit/>
+          </a:bodyPr>
+          <a:lstStyle/>
+          <a:p>
+            <a:pPr algn="l">
+              <a:spcAft>
+                <a:spcPts val="600"/>
+              </a:spcAft>
+            </a:pPr>
+            <a:r>
+              <a:rPr sz="1300" b="1" i="0">
+                <a:solidFill>
+                  <a:srgbClr val="FFFFFF"/>
+                </a:solidFill>
+                <a:latin typeface="Calibri"/>
+              </a:rPr>
+              <a:t>INFERENCE</a:t>
+            </a:r>
+          </a:p>
+        </p:txBody>
+      </p:sp>
+      <p:sp>
+        <p:nvSpPr>
+          <p:cNvPr id="14" name="Rectangle 13"/>
+          <p:cNvSpPr/>
+          <p:nvPr/>
+        </p:nvSpPr>
+        <p:spPr>
+          <a:xfrm>
+            <a:off x="4370832" y="2560320"/>
+            <a:ext cx="3703320" cy="3383280"/>
+          </a:xfrm>
+          <a:prstGeom prst="rect">
+            <a:avLst/>
+          </a:prstGeom>
+          <a:solidFill>
+            <a:srgbClr val="FFFFFF"/>
+          </a:solidFill>
+          <a:ln w="12700">
+            <a:solidFill>
+              <a:srgbClr val="E2DDEE"/>
+            </a:solidFill>
+          </a:ln>
+          <a:effectLst/>
+        </p:spPr>
+        <p:style>
+          <a:lnRef idx="1">
+            <a:schemeClr val="accent1"/>
+          </a:lnRef>
+          <a:fillRef idx="3">
+            <a:schemeClr val="accent1"/>
+          </a:fillRef>
+          <a:effectRef idx="2">
+            <a:schemeClr val="accent1"/>
+          </a:effectRef>
+          <a:fontRef idx="minor">
+            <a:schemeClr val="lt1"/>
+          </a:fontRef>
+        </p:style>
+        <p:txBody>
+          <a:bodyPr rtlCol="0" anchor="ctr"/>
+          <a:lstStyle/>
+          <a:p>
+            <a:pPr algn="ctr"/>
+          </a:p>
+        </p:txBody>
+      </p:sp>
+      <p:sp>
+        <p:nvSpPr>
+          <p:cNvPr id="15" name="TextBox 14"/>
+          <p:cNvSpPr txBox="1"/>
+          <p:nvPr/>
+        </p:nvSpPr>
+        <p:spPr>
+          <a:xfrm>
+            <a:off x="4572000" y="2697480"/>
+            <a:ext cx="3337560" cy="3200400"/>
+          </a:xfrm>
+          <a:prstGeom prst="rect">
+            <a:avLst/>
+          </a:prstGeom>
+          <a:noFill/>
+        </p:spPr>
+        <p:txBody>
+          <a:bodyPr wrap="square" anchor="t">
+            <a:spAutoFit/>
+          </a:bodyPr>
+          <a:lstStyle/>
+          <a:p>
+            <a:pPr>
+              <a:spcAft>
+                <a:spcPts val="900"/>
+              </a:spcAft>
+            </a:pPr>
+            <a:r>
+              <a:rPr sz="1150" b="1" i="0">
+                <a:solidFill>
+                  <a:srgbClr val="C4007A"/>
+                </a:solidFill>
+                <a:latin typeface="Consolas"/>
+              </a:rPr>
+              <a:t>POST /predict</a:t>
+            </a:r>
+            <a:r>
+              <a:rPr sz="1050" b="0" i="0">
+                <a:solidFill>
+                  <a:srgbClr val="222222"/>
+                </a:solidFill>
+                <a:latin typeface="Calibri"/>
+              </a:rPr>
+              <a:t>
+report from JPEG / PNG</a:t>
+            </a:r>
+          </a:p>
+          <a:p>
+            <a:pPr>
+              <a:spcAft>
+                <a:spcPts val="900"/>
+              </a:spcAft>
+            </a:pPr>
+            <a:r>
+              <a:rPr sz="1150" b="1" i="0">
+                <a:solidFill>
+                  <a:srgbClr val="C4007A"/>
+                </a:solidFill>
+                <a:latin typeface="Consolas"/>
+              </a:rPr>
+              <a:t>POST /predict/dicom</a:t>
+            </a:r>
+            <a:r>
+              <a:rPr sz="1050" b="0" i="0">
+                <a:solidFill>
+                  <a:srgbClr val="222222"/>
+                </a:solidFill>
+                <a:latin typeface="Calibri"/>
+              </a:rPr>
+              <a:t>
+report from a DICOM file</a:t>
+            </a:r>
+          </a:p>
+          <a:p>
+            <a:pPr>
+              <a:spcAft>
+                <a:spcPts val="900"/>
+              </a:spcAft>
+            </a:pPr>
+            <a:r>
+              <a:rPr sz="1150" b="1" i="0">
+                <a:solidFill>
+                  <a:srgbClr val="C4007A"/>
+                </a:solidFill>
+                <a:latin typeface="Consolas"/>
+              </a:rPr>
+              <a:t>POST /preview/dicom</a:t>
+            </a:r>
+            <a:r>
+              <a:rPr sz="1050" b="0" i="0">
+                <a:solidFill>
+                  <a:srgbClr val="222222"/>
+                </a:solidFill>
+                <a:latin typeface="Calibri"/>
+              </a:rPr>
+              <a:t>
+windowed DICOM preview image</a:t>
+            </a:r>
+          </a:p>
+          <a:p>
+            <a:pPr>
+              <a:spcAft>
+                <a:spcPts val="900"/>
+              </a:spcAft>
+            </a:pPr>
+            <a:r>
+              <a:rPr sz="1150" b="1" i="0">
+                <a:solidFill>
+                  <a:srgbClr val="C4007A"/>
+                </a:solidFill>
+                <a:latin typeface="Consolas"/>
+              </a:rPr>
+              <a:t>GET  /task/{id}</a:t>
+            </a:r>
+            <a:r>
+              <a:rPr sz="1050" b="0" i="0">
+                <a:solidFill>
+                  <a:srgbClr val="222222"/>
+                </a:solidFill>
+                <a:latin typeface="Calibri"/>
+              </a:rPr>
+              <a:t>
+poll an async job</a:t>
+            </a:r>
+          </a:p>
+        </p:txBody>
+      </p:sp>
+      <p:sp>
+        <p:nvSpPr>
+          <p:cNvPr id="16" name="Rectangle 15"/>
+          <p:cNvSpPr/>
+          <p:nvPr/>
+        </p:nvSpPr>
+        <p:spPr>
+          <a:xfrm>
+            <a:off x="8193024" y="2057400"/>
+            <a:ext cx="3703320" cy="502920"/>
+          </a:xfrm>
+          <a:prstGeom prst="rect">
+            <a:avLst/>
+          </a:prstGeom>
+          <a:solidFill>
+            <a:srgbClr val="009E8F"/>
+          </a:solidFill>
+          <a:ln>
+            <a:noFill/>
+          </a:ln>
+          <a:effectLst/>
+        </p:spPr>
+        <p:style>
+          <a:lnRef idx="1">
+            <a:schemeClr val="accent1"/>
+          </a:lnRef>
+          <a:fillRef idx="3">
+            <a:schemeClr val="accent1"/>
+          </a:fillRef>
+          <a:effectRef idx="2">
+            <a:schemeClr val="accent1"/>
+          </a:effectRef>
+          <a:fontRef idx="minor">
+            <a:schemeClr val="lt1"/>
+          </a:fontRef>
+        </p:style>
+        <p:txBody>
+          <a:bodyPr rtlCol="0" anchor="ctr"/>
+          <a:lstStyle/>
+          <a:p>
+            <a:pPr algn="ctr"/>
+          </a:p>
+        </p:txBody>
+      </p:sp>
+      <p:sp>
+        <p:nvSpPr>
+          <p:cNvPr id="17" name="TextBox 16"/>
+          <p:cNvSpPr txBox="1"/>
+          <p:nvPr/>
+        </p:nvSpPr>
+        <p:spPr>
+          <a:xfrm>
+            <a:off x="8375904" y="2084831"/>
+            <a:ext cx="3429000" cy="457200"/>
+          </a:xfrm>
+          <a:prstGeom prst="rect">
+            <a:avLst/>
+          </a:prstGeom>
+          <a:noFill/>
+        </p:spPr>
+        <p:txBody>
+          <a:bodyPr wrap="square" anchor="ctr">
+            <a:spAutoFit/>
+          </a:bodyPr>
+          <a:lstStyle/>
+          <a:p>
+            <a:pPr algn="l">
+              <a:spcAft>
+                <a:spcPts val="600"/>
+              </a:spcAft>
+            </a:pPr>
+            <a:r>
+              <a:rPr sz="1300" b="1" i="0">
+                <a:solidFill>
+                  <a:srgbClr val="FFFFFF"/>
+                </a:solidFill>
+                <a:latin typeface="Calibri"/>
+              </a:rPr>
+              <a:t>AGENT</a:t>
+            </a:r>
+          </a:p>
+        </p:txBody>
+      </p:sp>
+      <p:sp>
+        <p:nvSpPr>
+          <p:cNvPr id="18" name="Rectangle 17"/>
+          <p:cNvSpPr/>
+          <p:nvPr/>
+        </p:nvSpPr>
+        <p:spPr>
+          <a:xfrm>
+            <a:off x="8193024" y="2560320"/>
+            <a:ext cx="3703320" cy="3383280"/>
+          </a:xfrm>
+          <a:prstGeom prst="rect">
+            <a:avLst/>
+          </a:prstGeom>
+          <a:solidFill>
+            <a:srgbClr val="FFFFFF"/>
+          </a:solidFill>
+          <a:ln w="12700">
+            <a:solidFill>
+              <a:srgbClr val="E2DDEE"/>
+            </a:solidFill>
+          </a:ln>
+          <a:effectLst/>
+        </p:spPr>
+        <p:style>
+          <a:lnRef idx="1">
+            <a:schemeClr val="accent1"/>
+          </a:lnRef>
+          <a:fillRef idx="3">
+            <a:schemeClr val="accent1"/>
+          </a:fillRef>
+          <a:effectRef idx="2">
+            <a:schemeClr val="accent1"/>
+          </a:effectRef>
+          <a:fontRef idx="minor">
+            <a:schemeClr val="lt1"/>
+          </a:fontRef>
+        </p:style>
+        <p:txBody>
+          <a:bodyPr rtlCol="0" anchor="ctr"/>
+          <a:lstStyle/>
+          <a:p>
+            <a:pPr algn="ctr"/>
+          </a:p>
+        </p:txBody>
+      </p:sp>
+      <p:sp>
+        <p:nvSpPr>
+          <p:cNvPr id="19" name="TextBox 18"/>
+          <p:cNvSpPr txBox="1"/>
+          <p:nvPr/>
+        </p:nvSpPr>
+        <p:spPr>
+          <a:xfrm>
+            <a:off x="8394192" y="2697480"/>
+            <a:ext cx="3337560" cy="3200400"/>
+          </a:xfrm>
+          <a:prstGeom prst="rect">
+            <a:avLst/>
+          </a:prstGeom>
+          <a:noFill/>
+        </p:spPr>
+        <p:txBody>
+          <a:bodyPr wrap="square" anchor="t">
+            <a:spAutoFit/>
+          </a:bodyPr>
+          <a:lstStyle/>
+          <a:p>
+            <a:pPr>
+              <a:spcAft>
+                <a:spcPts val="900"/>
+              </a:spcAft>
+            </a:pPr>
+            <a:r>
+              <a:rPr sz="1150" b="1" i="0">
+                <a:solidFill>
+                  <a:srgbClr val="009E8F"/>
+                </a:solidFill>
+                <a:latin typeface="Consolas"/>
+              </a:rPr>
+              <a:t>POST /agent/query</a:t>
+            </a:r>
+            <a:r>
+              <a:rPr sz="1050" b="0" i="0">
+                <a:solidFill>
+                  <a:srgbClr val="222222"/>
+                </a:solidFill>
+                <a:latin typeface="Calibri"/>
+              </a:rPr>
+              <a:t>
+grounded question answering</a:t>
+            </a:r>
+          </a:p>
+          <a:p>
+            <a:pPr>
+              <a:spcAft>
+                <a:spcPts val="900"/>
+              </a:spcAft>
+            </a:pPr>
+            <a:r>
+              <a:rPr sz="1150" b="1" i="0">
+                <a:solidFill>
+                  <a:srgbClr val="009E8F"/>
+                </a:solidFill>
+                <a:latin typeface="Consolas"/>
+              </a:rPr>
+              <a:t>POST /agent/search</a:t>
+            </a:r>
+            <a:r>
+              <a:rPr sz="1050" b="0" i="0">
+                <a:solidFill>
+                  <a:srgbClr val="222222"/>
+                </a:solidFill>
+                <a:latin typeface="Calibri"/>
+              </a:rPr>
+              <a:t>
+semantic search over reports</a:t>
+            </a:r>
+          </a:p>
+          <a:p>
+            <a:pPr>
+              <a:spcAft>
+                <a:spcPts val="900"/>
+              </a:spcAft>
+            </a:pPr>
+            <a:r>
+              <a:rPr sz="1150" b="1" i="0">
+                <a:solidFill>
+                  <a:srgbClr val="009E8F"/>
+                </a:solidFill>
+                <a:latin typeface="Consolas"/>
+              </a:rPr>
+              <a:t>POST /agent/index</a:t>
+            </a:r>
+            <a:r>
+              <a:rPr sz="1050" b="0" i="0">
+                <a:solidFill>
+                  <a:srgbClr val="222222"/>
+                </a:solidFill>
+                <a:latin typeface="Calibri"/>
+              </a:rPr>
+              <a:t>
+add reports to the vector store</a:t>
+            </a:r>
+          </a:p>
+          <a:p>
+            <a:pPr>
+              <a:spcAft>
+                <a:spcPts val="900"/>
+              </a:spcAft>
+            </a:pPr>
+            <a:r>
+              <a:rPr sz="1150" b="1" i="0">
+                <a:solidFill>
+                  <a:srgbClr val="009E8F"/>
+                </a:solidFill>
+                <a:latin typeface="Consolas"/>
+              </a:rPr>
+              <a:t>GET  /agent/stats</a:t>
+            </a:r>
+            <a:r>
+              <a:rPr sz="1050" b="0" i="0">
+                <a:solidFill>
+                  <a:srgbClr val="222222"/>
+                </a:solidFill>
+                <a:latin typeface="Calibri"/>
+              </a:rPr>
+              <a:t>
+vector store statistics</a:t>
+            </a:r>
+          </a:p>
+        </p:txBody>
+      </p:sp>
+    </p:spTree>
+  </p:cSld>
+  <p:clrMapOvr>
+    <a:masterClrMapping/>
+  </p:clrMapOvr>
+</p:sld>
+</file>
+
+<file path=ppt/slides/slide9.xml><?xml version="1.0" encoding="utf-8"?>
+<p:sld xmlns:a="http://schemas.openxmlformats.org/drawingml/2006/main" xmlns:p="http://schemas.openxmlformats.org/presentationml/2006/main" xmlns:r="http://schemas.openxmlformats.org/officeDocument/2006/relationships">
+  <p:cSld>
+    <p:spTree>
+      <p:nvGrpSpPr>
+        <p:cNvPr id="1" name=""/>
+        <p:cNvGrpSpPr/>
+        <p:nvPr/>
+      </p:nvGrpSpPr>
+      <p:grpSpPr/>
+      <p:sp>
+        <p:nvSpPr>
+          <p:cNvPr id="2" name="Rectangle 1"/>
+          <p:cNvSpPr/>
+          <p:nvPr/>
+        </p:nvSpPr>
+        <p:spPr>
+          <a:xfrm>
+            <a:off x="0" y="0"/>
+            <a:ext cx="12191695" cy="1143000"/>
+          </a:xfrm>
+          <a:prstGeom prst="rect">
+            <a:avLst/>
+          </a:prstGeom>
+          <a:solidFill>
+            <a:srgbClr val="4B2E83"/>
+          </a:solidFill>
+          <a:ln>
+            <a:noFill/>
+          </a:ln>
+          <a:effectLst/>
+        </p:spPr>
+        <p:style>
+          <a:lnRef idx="1">
+            <a:schemeClr val="accent1"/>
+          </a:lnRef>
+          <a:fillRef idx="3">
+            <a:schemeClr val="accent1"/>
+          </a:fillRef>
+          <a:effectRef idx="2">
+            <a:schemeClr val="accent1"/>
+          </a:effectRef>
+          <a:fontRef idx="minor">
+            <a:schemeClr val="lt1"/>
+          </a:fontRef>
+        </p:style>
+        <p:txBody>
+          <a:bodyPr rtlCol="0" anchor="ctr"/>
+          <a:lstStyle/>
+          <a:p>
+            <a:pPr algn="ctr"/>
+          </a:p>
+        </p:txBody>
+      </p:sp>
+      <p:sp>
+        <p:nvSpPr>
+          <p:cNvPr id="3" name="Rectangle 2"/>
+          <p:cNvSpPr/>
+          <p:nvPr/>
+        </p:nvSpPr>
+        <p:spPr>
+          <a:xfrm>
+            <a:off x="0" y="1143000"/>
+            <a:ext cx="12191695" cy="54864"/>
+          </a:xfrm>
+          <a:prstGeom prst="rect">
+            <a:avLst/>
+          </a:prstGeom>
+          <a:solidFill>
+            <a:srgbClr val="C4007A"/>
+          </a:solidFill>
+          <a:ln>
+            <a:noFill/>
+          </a:ln>
+          <a:effectLst/>
+        </p:spPr>
+        <p:style>
+          <a:lnRef idx="1">
+            <a:schemeClr val="accent1"/>
+          </a:lnRef>
+          <a:fillRef idx="3">
+            <a:schemeClr val="accent1"/>
+          </a:fillRef>
+          <a:effectRef idx="2">
+            <a:schemeClr val="accent1"/>
+          </a:effectRef>
+          <a:fontRef idx="minor">
+            <a:schemeClr val="lt1"/>
+          </a:fontRef>
+        </p:style>
+        <p:txBody>
+          <a:bodyPr rtlCol="0" anchor="ctr"/>
+          <a:lstStyle/>
+          <a:p>
+            <a:pPr algn="ctr"/>
+          </a:p>
+        </p:txBody>
+      </p:sp>
+      <p:sp>
+        <p:nvSpPr>
+          <p:cNvPr id="4" name="TextBox 3"/>
+          <p:cNvSpPr txBox="1"/>
+          <p:nvPr/>
+        </p:nvSpPr>
+        <p:spPr>
+          <a:xfrm>
+            <a:off x="548640" y="164592"/>
+            <a:ext cx="10972800" cy="914400"/>
+          </a:xfrm>
+          <a:prstGeom prst="rect">
+            <a:avLst/>
+          </a:prstGeom>
+          <a:noFill/>
+        </p:spPr>
+        <p:txBody>
+          <a:bodyPr wrap="square" anchor="t">
+            <a:spAutoFit/>
+          </a:bodyPr>
+          <a:lstStyle/>
+          <a:p>
+            <a:pPr algn="l">
+              <a:spcAft>
                 <a:spcPts val="200"/>
               </a:spcAft>
             </a:pPr>
             <a:r>
-              <a:rPr sz="2400" b="1" i="0">
+              <a:rPr sz="1200" b="1" i="0">
+                <a:solidFill>
+                  <a:srgbClr val="D9C7F0"/>
+                </a:solidFill>
+                <a:latin typeface="Calibri"/>
+              </a:rPr>
+              <a:t>LIVE DEMO</a:t>
+            </a:r>
+          </a:p>
+          <a:p>
+            <a:pPr algn="l">
+              <a:spcAft>
+                <a:spcPts val="0"/>
+              </a:spcAft>
+            </a:pPr>
+            <a:r>
+              <a:rPr sz="2600" b="1" i="0">
                 <a:solidFill>
                   <a:srgbClr val="FFFFFF"/>
                 </a:solidFill>
                 <a:latin typeface="Calibri"/>
               </a:rPr>
-              <a:t>Thank You</a:t>
-            </a:r>
-          </a:p>
+              <a:t>What You'll See in the Screenshare</a:t>
+            </a:r>
+          </a:p>
+        </p:txBody>
+      </p:sp>
+      <p:sp>
+        <p:nvSpPr>
+          <p:cNvPr id="5" name="TextBox 4"/>
+          <p:cNvSpPr txBox="1"/>
+          <p:nvPr/>
+        </p:nvSpPr>
+        <p:spPr>
+          <a:xfrm>
+            <a:off x="365760" y="6446520"/>
+            <a:ext cx="8229600" cy="320040"/>
+          </a:xfrm>
+          <a:prstGeom prst="rect">
+            <a:avLst/>
+          </a:prstGeom>
+          <a:noFill/>
+        </p:spPr>
+        <p:txBody>
+          <a:bodyPr wrap="square" anchor="t">
+            <a:spAutoFit/>
+          </a:bodyPr>
+          <a:lstStyle/>
           <a:p>
             <a:pPr algn="l">
               <a:spcAft>
+                <a:spcPts val="600"/>
+              </a:spcAft>
+            </a:pPr>
+            <a:r>
+              <a:rPr sz="900" b="0" i="0">
+                <a:solidFill>
+                  <a:srgbClr val="5A5A5A"/>
+                </a:solidFill>
+                <a:latin typeface="Calibri"/>
+              </a:rPr>
+              <a:t>Cotiviti Intern Assessment  ·  Nitish Kumar  ·  San Jose State University</a:t>
+            </a:r>
+          </a:p>
+        </p:txBody>
+      </p:sp>
+      <p:sp>
+        <p:nvSpPr>
+          <p:cNvPr id="6" name="TextBox 5"/>
+          <p:cNvSpPr txBox="1"/>
+          <p:nvPr/>
+        </p:nvSpPr>
+        <p:spPr>
+          <a:xfrm>
+            <a:off x="11155680" y="6446520"/>
+            <a:ext cx="822960" cy="320040"/>
+          </a:xfrm>
+          <a:prstGeom prst="rect">
+            <a:avLst/>
+          </a:prstGeom>
+          <a:noFill/>
+        </p:spPr>
+        <p:txBody>
+          <a:bodyPr wrap="square" anchor="t">
+            <a:spAutoFit/>
+          </a:bodyPr>
+          <a:lstStyle/>
+          <a:p>
+            <a:pPr algn="r">
+              <a:spcAft>
+                <a:spcPts val="600"/>
+              </a:spcAft>
+            </a:pPr>
+            <a:r>
+              <a:rPr sz="900" b="0" i="0">
+                <a:solidFill>
+                  <a:srgbClr val="5A5A5A"/>
+                </a:solidFill>
+                <a:latin typeface="Calibri"/>
+              </a:rPr>
+              <a:t>9</a:t>
+            </a:r>
+          </a:p>
+        </p:txBody>
+      </p:sp>
+      <p:sp>
+        <p:nvSpPr>
+          <p:cNvPr id="7" name="Oval 6"/>
+          <p:cNvSpPr/>
+          <p:nvPr/>
+        </p:nvSpPr>
+        <p:spPr>
+          <a:xfrm>
+            <a:off x="640080" y="1755648"/>
+            <a:ext cx="201168" cy="201168"/>
+          </a:xfrm>
+          <a:prstGeom prst="ellipse">
+            <a:avLst/>
+          </a:prstGeom>
+          <a:solidFill>
+            <a:srgbClr val="C4007A"/>
+          </a:solidFill>
+          <a:ln>
+            <a:noFill/>
+          </a:ln>
+          <a:effectLst/>
+        </p:spPr>
+        <p:style>
+          <a:lnRef idx="1">
+            <a:schemeClr val="accent1"/>
+          </a:lnRef>
+          <a:fillRef idx="3">
+            <a:schemeClr val="accent1"/>
+          </a:fillRef>
+          <a:effectRef idx="2">
+            <a:schemeClr val="accent1"/>
+          </a:effectRef>
+          <a:fontRef idx="minor">
+            <a:schemeClr val="lt1"/>
+          </a:fontRef>
+        </p:style>
+        <p:txBody>
+          <a:bodyPr rtlCol="0" anchor="ctr"/>
+          <a:lstStyle/>
+          <a:p>
+            <a:pPr algn="ctr"/>
+          </a:p>
+        </p:txBody>
+      </p:sp>
+      <p:sp>
+        <p:nvSpPr>
+          <p:cNvPr id="8" name="TextBox 7"/>
+          <p:cNvSpPr txBox="1"/>
+          <p:nvPr/>
+        </p:nvSpPr>
+        <p:spPr>
+          <a:xfrm>
+            <a:off x="1051560" y="1645920"/>
+            <a:ext cx="10607040" cy="1005840"/>
+          </a:xfrm>
+          <a:prstGeom prst="rect">
+            <a:avLst/>
+          </a:prstGeom>
+          <a:noFill/>
+        </p:spPr>
+        <p:txBody>
+          <a:bodyPr wrap="square" anchor="t">
+            <a:spAutoFit/>
+          </a:bodyPr>
+          <a:lstStyle/>
+          <a:p>
+            <a:pPr algn="l">
+              <a:spcAft>
+                <a:spcPts val="200"/>
+              </a:spcAft>
+            </a:pPr>
+            <a:r>
+              <a:rPr sz="1600" b="1" i="0">
+                <a:solidFill>
+                  <a:srgbClr val="C4007A"/>
+                </a:solidFill>
+                <a:latin typeface="Calibri"/>
+              </a:rPr>
+              <a:t>Report Generation</a:t>
+            </a:r>
+          </a:p>
+          <a:p>
+            <a:pPr algn="l">
+              <a:spcAft>
                 <a:spcPts val="0"/>
               </a:spcAft>
             </a:pPr>
             <a:r>
               <a:rPr sz="1300" b="0" i="0">
                 <a:solidFill>
-                  <a:srgbClr val="D9C7F0"/>
-                </a:solidFill>
-                <a:latin typeface="Calibri"/>
-              </a:rPr>
-              <a:t>Nitish Kumar  ·  San Jose State University  ·  nitish.kumar@sjsu.edu</a:t>
+                  <a:srgbClr val="222222"/>
+                </a:solidFill>
+                <a:latin typeface="Calibri"/>
+              </a:rPr>
+              <a:t>Upload an X-ray and get a generated radiology report</a:t>
+            </a:r>
+          </a:p>
+        </p:txBody>
+      </p:sp>
+      <p:sp>
+        <p:nvSpPr>
+          <p:cNvPr id="9" name="Oval 8"/>
+          <p:cNvSpPr/>
+          <p:nvPr/>
+        </p:nvSpPr>
+        <p:spPr>
+          <a:xfrm>
+            <a:off x="640080" y="2834640"/>
+            <a:ext cx="201168" cy="201168"/>
+          </a:xfrm>
+          <a:prstGeom prst="ellipse">
+            <a:avLst/>
+          </a:prstGeom>
+          <a:solidFill>
+            <a:srgbClr val="4B2E83"/>
+          </a:solidFill>
+          <a:ln>
+            <a:noFill/>
+          </a:ln>
+          <a:effectLst/>
+        </p:spPr>
+        <p:style>
+          <a:lnRef idx="1">
+            <a:schemeClr val="accent1"/>
+          </a:lnRef>
+          <a:fillRef idx="3">
+            <a:schemeClr val="accent1"/>
+          </a:fillRef>
+          <a:effectRef idx="2">
+            <a:schemeClr val="accent1"/>
+          </a:effectRef>
+          <a:fontRef idx="minor">
+            <a:schemeClr val="lt1"/>
+          </a:fontRef>
+        </p:style>
+        <p:txBody>
+          <a:bodyPr rtlCol="0" anchor="ctr"/>
+          <a:lstStyle/>
+          <a:p>
+            <a:pPr algn="ctr"/>
+          </a:p>
+        </p:txBody>
+      </p:sp>
+      <p:sp>
+        <p:nvSpPr>
+          <p:cNvPr id="10" name="TextBox 9"/>
+          <p:cNvSpPr txBox="1"/>
+          <p:nvPr/>
+        </p:nvSpPr>
+        <p:spPr>
+          <a:xfrm>
+            <a:off x="1051560" y="2724912"/>
+            <a:ext cx="10607040" cy="1005840"/>
+          </a:xfrm>
+          <a:prstGeom prst="rect">
+            <a:avLst/>
+          </a:prstGeom>
+          <a:noFill/>
+        </p:spPr>
+        <p:txBody>
+          <a:bodyPr wrap="square" anchor="t">
+            <a:spAutoFit/>
+          </a:bodyPr>
+          <a:lstStyle/>
+          <a:p>
+            <a:pPr algn="l">
+              <a:spcAft>
+                <a:spcPts val="200"/>
+              </a:spcAft>
+            </a:pPr>
+            <a:r>
+              <a:rPr sz="1600" b="1" i="0">
+                <a:solidFill>
+                  <a:srgbClr val="4B2E83"/>
+                </a:solidFill>
+                <a:latin typeface="Calibri"/>
+              </a:rPr>
+              <a:t>Clinical Agent</a:t>
+            </a:r>
+          </a:p>
+          <a:p>
+            <a:pPr algn="l">
+              <a:spcAft>
+                <a:spcPts val="0"/>
+              </a:spcAft>
+            </a:pPr>
+            <a:r>
+              <a:rPr sz="1300" b="0" i="0">
+                <a:solidFill>
+                  <a:srgbClr val="222222"/>
+                </a:solidFill>
+                <a:latin typeface="Calibri"/>
+              </a:rPr>
+              <a:t>Ask a clinical question, see the step-by-step reasoning and a grounded answer</a:t>
+            </a:r>
+          </a:p>
+        </p:txBody>
+      </p:sp>
+      <p:sp>
+        <p:nvSpPr>
+          <p:cNvPr id="11" name="Oval 10"/>
+          <p:cNvSpPr/>
+          <p:nvPr/>
+        </p:nvSpPr>
+        <p:spPr>
+          <a:xfrm>
+            <a:off x="640080" y="3913632"/>
+            <a:ext cx="201168" cy="201168"/>
+          </a:xfrm>
+          <a:prstGeom prst="ellipse">
+            <a:avLst/>
+          </a:prstGeom>
+          <a:solidFill>
+            <a:srgbClr val="009E8F"/>
+          </a:solidFill>
+          <a:ln>
+            <a:noFill/>
+          </a:ln>
+          <a:effectLst/>
+        </p:spPr>
+        <p:style>
+          <a:lnRef idx="1">
+            <a:schemeClr val="accent1"/>
+          </a:lnRef>
+          <a:fillRef idx="3">
+            <a:schemeClr val="accent1"/>
+          </a:fillRef>
+          <a:effectRef idx="2">
+            <a:schemeClr val="accent1"/>
+          </a:effectRef>
+          <a:fontRef idx="minor">
+            <a:schemeClr val="lt1"/>
+          </a:fontRef>
+        </p:style>
+        <p:txBody>
+          <a:bodyPr rtlCol="0" anchor="ctr"/>
+          <a:lstStyle/>
+          <a:p>
+            <a:pPr algn="ctr"/>
+          </a:p>
+        </p:txBody>
+      </p:sp>
+      <p:sp>
+        <p:nvSpPr>
+          <p:cNvPr id="12" name="TextBox 11"/>
+          <p:cNvSpPr txBox="1"/>
+          <p:nvPr/>
+        </p:nvSpPr>
+        <p:spPr>
+          <a:xfrm>
+            <a:off x="1051560" y="3803904"/>
+            <a:ext cx="10607040" cy="1005840"/>
+          </a:xfrm>
+          <a:prstGeom prst="rect">
+            <a:avLst/>
+          </a:prstGeom>
+          <a:noFill/>
+        </p:spPr>
+        <p:txBody>
+          <a:bodyPr wrap="square" anchor="t">
+            <a:spAutoFit/>
+          </a:bodyPr>
+          <a:lstStyle/>
+          <a:p>
+            <a:pPr algn="l">
+              <a:spcAft>
+                <a:spcPts val="200"/>
+              </a:spcAft>
+            </a:pPr>
+            <a:r>
+              <a:rPr sz="1600" b="1" i="0">
+                <a:solidFill>
+                  <a:srgbClr val="009E8F"/>
+                </a:solidFill>
+                <a:latin typeface="Calibri"/>
+              </a:rPr>
+              <a:t>Knowledge Base</a:t>
+            </a:r>
+          </a:p>
+          <a:p>
+            <a:pPr algn="l">
+              <a:spcAft>
+                <a:spcPts val="0"/>
+              </a:spcAft>
+            </a:pPr>
+            <a:r>
+              <a:rPr sz="1300" b="0" i="0">
+                <a:solidFill>
+                  <a:srgbClr val="222222"/>
+                </a:solidFill>
+                <a:latin typeface="Calibri"/>
+              </a:rPr>
+              <a:t>Add reports, search by meaning, and manage the vector store</a:t>
+            </a:r>
+          </a:p>
+        </p:txBody>
+      </p:sp>
+      <p:sp>
+        <p:nvSpPr>
+          <p:cNvPr id="13" name="Oval 12"/>
+          <p:cNvSpPr/>
+          <p:nvPr/>
+        </p:nvSpPr>
+        <p:spPr>
+          <a:xfrm>
+            <a:off x="640080" y="4992624"/>
+            <a:ext cx="201168" cy="201168"/>
+          </a:xfrm>
+          <a:prstGeom prst="ellipse">
+            <a:avLst/>
+          </a:prstGeom>
+          <a:solidFill>
+            <a:srgbClr val="E07A00"/>
+          </a:solidFill>
+          <a:ln>
+            <a:noFill/>
+          </a:ln>
+          <a:effectLst/>
+        </p:spPr>
+        <p:style>
+          <a:lnRef idx="1">
+            <a:schemeClr val="accent1"/>
+          </a:lnRef>
+          <a:fillRef idx="3">
+            <a:schemeClr val="accent1"/>
+          </a:fillRef>
+          <a:effectRef idx="2">
+            <a:schemeClr val="accent1"/>
+          </a:effectRef>
+          <a:fontRef idx="minor">
+            <a:schemeClr val="lt1"/>
+          </a:fontRef>
+        </p:style>
+        <p:txBody>
+          <a:bodyPr rtlCol="0" anchor="ctr"/>
+          <a:lstStyle/>
+          <a:p>
+            <a:pPr algn="ctr"/>
+          </a:p>
+        </p:txBody>
+      </p:sp>
+      <p:sp>
+        <p:nvSpPr>
+          <p:cNvPr id="14" name="TextBox 13"/>
+          <p:cNvSpPr txBox="1"/>
+          <p:nvPr/>
+        </p:nvSpPr>
+        <p:spPr>
+          <a:xfrm>
+            <a:off x="1051560" y="4882896"/>
+            <a:ext cx="10607040" cy="1005840"/>
+          </a:xfrm>
+          <a:prstGeom prst="rect">
+            <a:avLst/>
+          </a:prstGeom>
+          <a:noFill/>
+        </p:spPr>
+        <p:txBody>
+          <a:bodyPr wrap="square" anchor="t">
+            <a:spAutoFit/>
+          </a:bodyPr>
+          <a:lstStyle/>
+          <a:p>
+            <a:pPr algn="l">
+              <a:spcAft>
+                <a:spcPts val="200"/>
+              </a:spcAft>
+            </a:pPr>
+            <a:r>
+              <a:rPr sz="1600" b="1" i="0">
+                <a:solidFill>
+                  <a:srgbClr val="E07A00"/>
+                </a:solidFill>
+                <a:latin typeface="Calibri"/>
+              </a:rPr>
+              <a:t>System and Telemetry</a:t>
+            </a:r>
+          </a:p>
+          <a:p>
+            <a:pPr algn="l">
+              <a:spcAft>
+                <a:spcPts val="0"/>
+              </a:spcAft>
+            </a:pPr>
+            <a:r>
+              <a:rPr sz="1300" b="0" i="0">
+                <a:solidFill>
+                  <a:srgbClr val="222222"/>
+                </a:solidFill>
+                <a:latin typeface="Calibri"/>
+              </a:rPr>
+              <a:t>Live health, Prometheus metrics, OpenTelemetry status</a:t>
             </a:r>
           </a:p>
         </p:txBody>

</xml_diff>